<commit_message>
update slides to add more explantion abput core number
</commit_message>
<xml_diff>
--- a/docs/meeting/2026_05_06_for_investors_core_number.pptx
+++ b/docs/meeting/2026_05_06_for_investors_core_number.pptx
@@ -5,7 +5,7 @@
     <p:sldMasterId id="2147483648" r:id="rId1"/>
   </p:sldMasterIdLst>
   <p:notesMasterIdLst>
-    <p:notesMasterId r:id="rId13"/>
+    <p:notesMasterId r:id="rId14"/>
   </p:notesMasterIdLst>
   <p:sldIdLst>
     <p:sldId id="1574" r:id="rId2"/>
@@ -16,9 +16,10 @@
     <p:sldId id="1727" r:id="rId7"/>
     <p:sldId id="1681" r:id="rId8"/>
     <p:sldId id="1718" r:id="rId9"/>
-    <p:sldId id="1715" r:id="rId10"/>
-    <p:sldId id="1716" r:id="rId11"/>
-    <p:sldId id="1696" r:id="rId12"/>
+    <p:sldId id="1719" r:id="rId10"/>
+    <p:sldId id="1715" r:id="rId11"/>
+    <p:sldId id="1716" r:id="rId12"/>
+    <p:sldId id="1696" r:id="rId13"/>
   </p:sldIdLst>
   <p:sldSz cx="12192000" cy="6858000"/>
   <p:notesSz cx="6858000" cy="9144000"/>
@@ -130,6 +131,7 @@
             <p14:sldId id="1727"/>
             <p14:sldId id="1681"/>
             <p14:sldId id="1718"/>
+            <p14:sldId id="1719"/>
             <p14:sldId id="1715"/>
             <p14:sldId id="1716"/>
             <p14:sldId id="1696"/>
@@ -266,7 +268,7 @@
           <a:p>
             <a:fld id="{2915196C-CDBC-4DEE-A220-849C85FC22AC}" type="datetimeFigureOut">
               <a:rPr lang="he-IL" smtClean="0"/>
-              <a:t>כ"ג/אייר/תשפ"ו</a:t>
+              <a:t>א'/סיון/תשפ"ו</a:t>
             </a:fld>
             <a:endParaRPr lang="he-IL"/>
           </a:p>
@@ -835,7 +837,7 @@
           <a:p>
             <a:fld id="{FC6B3A86-AB79-4388-8CA5-9FC4B834779B}" type="datetime8">
               <a:rPr lang="he-IL" smtClean="0"/>
-              <a:t>10 מאי 26</a:t>
+              <a:t>17 מאי 26</a:t>
             </a:fld>
             <a:endParaRPr lang="he-IL"/>
           </a:p>
@@ -1058,7 +1060,7 @@
           <a:p>
             <a:fld id="{18F56BC8-8E7D-4896-9980-77BC87FB8E3E}" type="datetime8">
               <a:rPr lang="he-IL" smtClean="0"/>
-              <a:t>10 מאי 26</a:t>
+              <a:t>17 מאי 26</a:t>
             </a:fld>
             <a:endParaRPr lang="he-IL"/>
           </a:p>
@@ -1291,7 +1293,7 @@
           <a:p>
             <a:fld id="{0FE327C8-CB36-417E-834B-544633ADCE63}" type="datetime8">
               <a:rPr lang="he-IL" smtClean="0"/>
-              <a:t>10 מאי 26</a:t>
+              <a:t>17 מאי 26</a:t>
             </a:fld>
             <a:endParaRPr lang="he-IL"/>
           </a:p>
@@ -1409,7 +1411,7 @@
           <a:p>
             <a:fld id="{8E065D1C-C98B-44F5-AB2A-FEE3E85D0A94}" type="datetime8">
               <a:rPr lang="he-IL" smtClean="0"/>
-              <a:t>10 מאי 26</a:t>
+              <a:t>17 מאי 26</a:t>
             </a:fld>
             <a:endParaRPr lang="he-IL"/>
           </a:p>
@@ -1724,7 +1726,7 @@
           <a:p>
             <a:fld id="{7634CBFB-2532-48BA-BAE2-ADD925390740}" type="datetime8">
               <a:rPr lang="he-IL" smtClean="0"/>
-              <a:t>10 מאי 26</a:t>
+              <a:t>17 מאי 26</a:t>
             </a:fld>
             <a:endParaRPr lang="he-IL"/>
           </a:p>
@@ -2007,7 +2009,7 @@
           <a:p>
             <a:fld id="{8EAC1FDD-37C4-4A6B-BF31-779943CE32CF}" type="datetime8">
               <a:rPr lang="he-IL" smtClean="0"/>
-              <a:t>10 מאי 26</a:t>
+              <a:t>17 מאי 26</a:t>
             </a:fld>
             <a:endParaRPr lang="he-IL"/>
           </a:p>
@@ -2320,7 +2322,7 @@
           <a:p>
             <a:fld id="{C73C226C-A76A-4927-8F1D-1BD4AC033ABB}" type="datetime8">
               <a:rPr lang="he-IL" smtClean="0"/>
-              <a:t>10 מאי 26</a:t>
+              <a:t>17 מאי 26</a:t>
             </a:fld>
             <a:endParaRPr lang="he-IL"/>
           </a:p>
@@ -2823,7 +2825,7 @@
           <a:p>
             <a:fld id="{430DF2BF-D428-43E9-B36B-6DD16CF93579}" type="datetime8">
               <a:rPr lang="he-IL" smtClean="0"/>
-              <a:t>10 מאי 26</a:t>
+              <a:t>17 מאי 26</a:t>
             </a:fld>
             <a:endParaRPr lang="he-IL"/>
           </a:p>
@@ -2970,7 +2972,7 @@
           <a:p>
             <a:fld id="{390A9136-4922-4C74-B05C-12CD0951E601}" type="datetime8">
               <a:rPr lang="he-IL" smtClean="0"/>
-              <a:t>10 מאי 26</a:t>
+              <a:t>17 מאי 26</a:t>
             </a:fld>
             <a:endParaRPr lang="he-IL"/>
           </a:p>
@@ -3088,7 +3090,7 @@
           <a:p>
             <a:fld id="{C29F3CA8-2E63-412C-AA06-0D760EBE5965}" type="datetime8">
               <a:rPr lang="he-IL" smtClean="0"/>
-              <a:t>10 מאי 26</a:t>
+              <a:t>17 מאי 26</a:t>
             </a:fld>
             <a:endParaRPr lang="he-IL"/>
           </a:p>
@@ -3410,7 +3412,7 @@
           <a:p>
             <a:fld id="{7AC7B867-AA4A-4FF3-AD8B-0AD0F18EE595}" type="datetime8">
               <a:rPr lang="he-IL" smtClean="0"/>
-              <a:t>10 מאי 26</a:t>
+              <a:t>17 מאי 26</a:t>
             </a:fld>
             <a:endParaRPr lang="he-IL"/>
           </a:p>
@@ -3708,7 +3710,7 @@
           <a:p>
             <a:fld id="{F5E9EBD3-88E8-46DB-BD3B-F935B7013014}" type="datetime8">
               <a:rPr lang="he-IL" smtClean="0"/>
-              <a:t>10 מאי 26</a:t>
+              <a:t>17 מאי 26</a:t>
             </a:fld>
             <a:endParaRPr lang="he-IL"/>
           </a:p>
@@ -3992,7 +3994,7 @@
           <a:p>
             <a:fld id="{8E065D1C-C98B-44F5-AB2A-FEE3E85D0A94}" type="datetime8">
               <a:rPr lang="he-IL" smtClean="0"/>
-              <a:t>10 מאי 26</a:t>
+              <a:t>17 מאי 26</a:t>
             </a:fld>
             <a:endParaRPr lang="he-IL"/>
           </a:p>
@@ -5121,6 +5123,303 @@
         <p:cNvPr id="1" name="">
           <a:extLst>
             <a:ext uri="{FF2B5EF4-FFF2-40B4-BE49-F238E27FC236}">
+              <a16:creationId xmlns:a16="http://schemas.microsoft.com/office/drawing/2014/main" id="{F1FAB34D-2D7A-F556-495E-0CBC96104FEC}"/>
+            </a:ext>
+          </a:extLst>
+        </p:cNvPr>
+        <p:cNvGrpSpPr/>
+        <p:nvPr/>
+      </p:nvGrpSpPr>
+      <p:grpSpPr>
+        <a:xfrm>
+          <a:off x="0" y="0"/>
+          <a:ext cx="0" cy="0"/>
+          <a:chOff x="0" y="0"/>
+          <a:chExt cx="0" cy="0"/>
+        </a:xfrm>
+      </p:grpSpPr>
+      <p:pic>
+        <p:nvPicPr>
+          <p:cNvPr id="6" name="Picture 5">
+            <a:extLst>
+              <a:ext uri="{FF2B5EF4-FFF2-40B4-BE49-F238E27FC236}">
+                <a16:creationId xmlns:a16="http://schemas.microsoft.com/office/drawing/2014/main" id="{D1AEA69D-040E-DE12-FF0B-4330D7D19F20}"/>
+              </a:ext>
+            </a:extLst>
+          </p:cNvPr>
+          <p:cNvPicPr>
+            <a:picLocks noChangeAspect="1"/>
+          </p:cNvPicPr>
+          <p:nvPr/>
+        </p:nvPicPr>
+        <p:blipFill>
+          <a:blip r:embed="rId2"/>
+          <a:stretch>
+            <a:fillRect/>
+          </a:stretch>
+        </p:blipFill>
+        <p:spPr>
+          <a:xfrm>
+            <a:off x="269377" y="2061292"/>
+            <a:ext cx="5826623" cy="2735414"/>
+          </a:xfrm>
+          <a:prstGeom prst="rect">
+            <a:avLst/>
+          </a:prstGeom>
+        </p:spPr>
+      </p:pic>
+      <p:pic>
+        <p:nvPicPr>
+          <p:cNvPr id="9" name="Picture 8">
+            <a:extLst>
+              <a:ext uri="{FF2B5EF4-FFF2-40B4-BE49-F238E27FC236}">
+                <a16:creationId xmlns:a16="http://schemas.microsoft.com/office/drawing/2014/main" id="{7E1F8EA2-71D6-580F-81B8-0F2F2C7F43D3}"/>
+              </a:ext>
+            </a:extLst>
+          </p:cNvPr>
+          <p:cNvPicPr>
+            <a:picLocks noChangeAspect="1"/>
+          </p:cNvPicPr>
+          <p:nvPr/>
+        </p:nvPicPr>
+        <p:blipFill>
+          <a:blip r:embed="rId3"/>
+          <a:stretch>
+            <a:fillRect/>
+          </a:stretch>
+        </p:blipFill>
+        <p:spPr>
+          <a:xfrm>
+            <a:off x="6226073" y="2114567"/>
+            <a:ext cx="5599670" cy="2628865"/>
+          </a:xfrm>
+          <a:prstGeom prst="rect">
+            <a:avLst/>
+          </a:prstGeom>
+        </p:spPr>
+      </p:pic>
+      <p:sp>
+        <p:nvSpPr>
+          <p:cNvPr id="2" name="Title 1">
+            <a:extLst>
+              <a:ext uri="{FF2B5EF4-FFF2-40B4-BE49-F238E27FC236}">
+                <a16:creationId xmlns:a16="http://schemas.microsoft.com/office/drawing/2014/main" id="{7A8FD990-DDE6-CBC9-B3A6-00D4121DA222}"/>
+              </a:ext>
+            </a:extLst>
+          </p:cNvPr>
+          <p:cNvSpPr>
+            <a:spLocks noGrp="1"/>
+          </p:cNvSpPr>
+          <p:nvPr>
+            <p:ph type="title"/>
+          </p:nvPr>
+        </p:nvSpPr>
+        <p:spPr/>
+        <p:txBody>
+          <a:bodyPr>
+            <a:normAutofit/>
+          </a:bodyPr>
+          <a:lstStyle/>
+          <a:p>
+            <a:r>
+              <a:rPr lang="en-GB" dirty="0"/>
+              <a:t>Core Number Analysis</a:t>
+            </a:r>
+            <a:br>
+              <a:rPr lang="en-GB" dirty="0"/>
+            </a:br>
+            <a:r>
+              <a:rPr lang="en-GB" sz="2400" dirty="0"/>
+              <a:t>group mode: smaller</a:t>
+            </a:r>
+            <a:endParaRPr lang="en-IL" sz="2400" dirty="0"/>
+          </a:p>
+        </p:txBody>
+      </p:sp>
+      <p:sp>
+        <p:nvSpPr>
+          <p:cNvPr id="3" name="Content Placeholder 2">
+            <a:extLst>
+              <a:ext uri="{FF2B5EF4-FFF2-40B4-BE49-F238E27FC236}">
+                <a16:creationId xmlns:a16="http://schemas.microsoft.com/office/drawing/2014/main" id="{DC55D22E-3792-2DD2-21B2-D8ADB8E10260}"/>
+              </a:ext>
+            </a:extLst>
+          </p:cNvPr>
+          <p:cNvSpPr>
+            <a:spLocks noGrp="1"/>
+          </p:cNvSpPr>
+          <p:nvPr>
+            <p:ph idx="1"/>
+          </p:nvPr>
+        </p:nvSpPr>
+        <p:spPr>
+          <a:xfrm>
+            <a:off x="1243086" y="1825624"/>
+            <a:ext cx="10850301" cy="5004149"/>
+          </a:xfrm>
+        </p:spPr>
+        <p:txBody>
+          <a:bodyPr>
+            <a:normAutofit/>
+          </a:bodyPr>
+          <a:lstStyle/>
+          <a:p>
+            <a:pPr marL="0" indent="0">
+              <a:buNone/>
+            </a:pPr>
+            <a:endParaRPr lang="en-GB" sz="2000" b="1" dirty="0"/>
+          </a:p>
+          <a:p>
+            <a:pPr lvl="2"/>
+            <a:endParaRPr lang="en-GB" sz="1500" dirty="0"/>
+          </a:p>
+          <a:p>
+            <a:pPr marL="914400" lvl="2" indent="0">
+              <a:buNone/>
+            </a:pPr>
+            <a:endParaRPr lang="en-GB" sz="1500" dirty="0"/>
+          </a:p>
+        </p:txBody>
+      </p:sp>
+      <p:sp>
+        <p:nvSpPr>
+          <p:cNvPr id="4" name="Slide Number Placeholder 3">
+            <a:extLst>
+              <a:ext uri="{FF2B5EF4-FFF2-40B4-BE49-F238E27FC236}">
+                <a16:creationId xmlns:a16="http://schemas.microsoft.com/office/drawing/2014/main" id="{C96BD006-7CBF-5F23-2244-43E7DEA5E1B7}"/>
+              </a:ext>
+            </a:extLst>
+          </p:cNvPr>
+          <p:cNvSpPr>
+            <a:spLocks noGrp="1"/>
+          </p:cNvSpPr>
+          <p:nvPr>
+            <p:ph type="sldNum" sz="quarter" idx="12"/>
+          </p:nvPr>
+        </p:nvSpPr>
+        <p:spPr/>
+        <p:txBody>
+          <a:bodyPr/>
+          <a:lstStyle/>
+          <a:p>
+            <a:fld id="{E6AB8EDD-9EF2-4633-A1C2-4D908C1019B4}" type="slidenum">
+              <a:rPr lang="he-IL" smtClean="0"/>
+              <a:t>10</a:t>
+            </a:fld>
+            <a:endParaRPr lang="he-IL"/>
+          </a:p>
+        </p:txBody>
+      </p:sp>
+      <p:sp>
+        <p:nvSpPr>
+          <p:cNvPr id="11" name="TextBox 10">
+            <a:extLst>
+              <a:ext uri="{FF2B5EF4-FFF2-40B4-BE49-F238E27FC236}">
+                <a16:creationId xmlns:a16="http://schemas.microsoft.com/office/drawing/2014/main" id="{4B8F8192-2756-715E-FCCA-8DD01E5AA434}"/>
+              </a:ext>
+            </a:extLst>
+          </p:cNvPr>
+          <p:cNvSpPr txBox="1"/>
+          <p:nvPr/>
+        </p:nvSpPr>
+        <p:spPr>
+          <a:xfrm>
+            <a:off x="1527433" y="5217459"/>
+            <a:ext cx="7073153" cy="646331"/>
+          </a:xfrm>
+          <a:prstGeom prst="rect">
+            <a:avLst/>
+          </a:prstGeom>
+          <a:noFill/>
+        </p:spPr>
+        <p:txBody>
+          <a:bodyPr wrap="square" rtlCol="0">
+            <a:spAutoFit/>
+          </a:bodyPr>
+          <a:lstStyle/>
+          <a:p>
+            <a:r>
+              <a:rPr lang="en-GB" b="1" dirty="0"/>
+              <a:t>Group mode: smaller</a:t>
+            </a:r>
+            <a:r>
+              <a:rPr lang="en-GB" dirty="0"/>
+              <a:t> - each point represents authors whose indicator value is </a:t>
+            </a:r>
+            <a:r>
+              <a:rPr lang="en-GB" b="1" dirty="0"/>
+              <a:t>less than</a:t>
+            </a:r>
+            <a:r>
+              <a:rPr lang="en-GB" dirty="0"/>
+              <a:t> the x-axis value.</a:t>
+            </a:r>
+            <a:endParaRPr lang="en-IL" dirty="0"/>
+          </a:p>
+        </p:txBody>
+      </p:sp>
+      <p:sp>
+        <p:nvSpPr>
+          <p:cNvPr id="5" name="TextBox 4">
+            <a:extLst>
+              <a:ext uri="{FF2B5EF4-FFF2-40B4-BE49-F238E27FC236}">
+                <a16:creationId xmlns:a16="http://schemas.microsoft.com/office/drawing/2014/main" id="{41A45B88-BBA4-ED58-4469-C910CCAA9BA6}"/>
+              </a:ext>
+            </a:extLst>
+          </p:cNvPr>
+          <p:cNvSpPr txBox="1"/>
+          <p:nvPr/>
+        </p:nvSpPr>
+        <p:spPr>
+          <a:xfrm>
+            <a:off x="5234722" y="1639613"/>
+            <a:ext cx="2214283" cy="369332"/>
+          </a:xfrm>
+          <a:prstGeom prst="rect">
+            <a:avLst/>
+          </a:prstGeom>
+          <a:noFill/>
+        </p:spPr>
+        <p:txBody>
+          <a:bodyPr wrap="square" rtlCol="0">
+            <a:spAutoFit/>
+          </a:bodyPr>
+          <a:lstStyle/>
+          <a:p>
+            <a:pPr algn="ctr"/>
+            <a:r>
+              <a:rPr lang="en-US" dirty="0"/>
+              <a:t>Ecuador </a:t>
+            </a:r>
+            <a:r>
+              <a:rPr lang="en-GB" dirty="0"/>
+              <a:t>Campaigns</a:t>
+            </a:r>
+            <a:endParaRPr lang="en-IL" dirty="0"/>
+          </a:p>
+        </p:txBody>
+      </p:sp>
+    </p:spTree>
+    <p:extLst>
+      <p:ext uri="{BB962C8B-B14F-4D97-AF65-F5344CB8AC3E}">
+        <p14:creationId xmlns:p14="http://schemas.microsoft.com/office/powerpoint/2010/main" val="3953363932"/>
+      </p:ext>
+    </p:extLst>
+  </p:cSld>
+  <p:clrMapOvr>
+    <a:masterClrMapping/>
+  </p:clrMapOvr>
+</p:sld>
+</file>
+
+<file path=ppt/slides/slide11.xml><?xml version="1.0" encoding="utf-8"?>
+<p:sld xmlns:a="http://schemas.openxmlformats.org/drawingml/2006/main" xmlns:r="http://schemas.openxmlformats.org/officeDocument/2006/relationships" xmlns:p="http://schemas.openxmlformats.org/presentationml/2006/main">
+  <p:cSld>
+    <p:spTree>
+      <p:nvGrpSpPr>
+        <p:cNvPr id="1" name="">
+          <a:extLst>
+            <a:ext uri="{FF2B5EF4-FFF2-40B4-BE49-F238E27FC236}">
               <a16:creationId xmlns:a16="http://schemas.microsoft.com/office/drawing/2014/main" id="{C3076A3C-FA4E-8A3B-4630-F74A2E6B05C1}"/>
             </a:ext>
           </a:extLst>
@@ -5302,7 +5601,7 @@
           <a:p>
             <a:fld id="{E6AB8EDD-9EF2-4633-A1C2-4D908C1019B4}" type="slidenum">
               <a:rPr lang="he-IL" smtClean="0"/>
-              <a:t>10</a:t>
+              <a:t>11</a:t>
             </a:fld>
             <a:endParaRPr lang="he-IL"/>
           </a:p>
@@ -5410,7 +5709,7 @@
 </p:sld>
 </file>
 
-<file path=ppt/slides/slide11.xml><?xml version="1.0" encoding="utf-8"?>
+<file path=ppt/slides/slide12.xml><?xml version="1.0" encoding="utf-8"?>
 <p:sld xmlns:a="http://schemas.openxmlformats.org/drawingml/2006/main" xmlns:r="http://schemas.openxmlformats.org/officeDocument/2006/relationships" xmlns:p="http://schemas.openxmlformats.org/presentationml/2006/main">
   <p:cSld>
     <p:spTree>
@@ -5590,7 +5889,7 @@
           <a:p>
             <a:fld id="{E6AB8EDD-9EF2-4633-A1C2-4D908C1019B4}" type="slidenum">
               <a:rPr lang="he-IL" smtClean="0"/>
-              <a:t>11</a:t>
+              <a:t>12</a:t>
             </a:fld>
             <a:endParaRPr lang="he-IL"/>
           </a:p>
@@ -7413,6 +7712,130 @@
 </file>
 
 <file path=ppt/slides/slide8.xml><?xml version="1.0" encoding="utf-8"?>
+<p:sld xmlns:a="http://schemas.openxmlformats.org/drawingml/2006/main" xmlns:r="http://schemas.openxmlformats.org/officeDocument/2006/relationships" xmlns:p="http://schemas.openxmlformats.org/presentationml/2006/main" show="0">
+  <p:cSld>
+    <p:spTree>
+      <p:nvGrpSpPr>
+        <p:cNvPr id="1" name="">
+          <a:extLst>
+            <a:ext uri="{FF2B5EF4-FFF2-40B4-BE49-F238E27FC236}">
+              <a16:creationId xmlns:a16="http://schemas.microsoft.com/office/drawing/2014/main" id="{6591E3BC-962E-008E-4A26-C2135A4B29F4}"/>
+            </a:ext>
+          </a:extLst>
+        </p:cNvPr>
+        <p:cNvGrpSpPr/>
+        <p:nvPr/>
+      </p:nvGrpSpPr>
+      <p:grpSpPr>
+        <a:xfrm>
+          <a:off x="0" y="0"/>
+          <a:ext cx="0" cy="0"/>
+          <a:chOff x="0" y="0"/>
+          <a:chExt cx="0" cy="0"/>
+        </a:xfrm>
+      </p:grpSpPr>
+      <p:sp>
+        <p:nvSpPr>
+          <p:cNvPr id="2" name="Title 1">
+            <a:extLst>
+              <a:ext uri="{FF2B5EF4-FFF2-40B4-BE49-F238E27FC236}">
+                <a16:creationId xmlns:a16="http://schemas.microsoft.com/office/drawing/2014/main" id="{E7D3E1A7-B397-F9BA-7ECB-4DA1358CD3FE}"/>
+              </a:ext>
+            </a:extLst>
+          </p:cNvPr>
+          <p:cNvSpPr>
+            <a:spLocks noGrp="1"/>
+          </p:cNvSpPr>
+          <p:nvPr>
+            <p:ph type="title"/>
+          </p:nvPr>
+        </p:nvSpPr>
+        <p:spPr/>
+        <p:txBody>
+          <a:bodyPr/>
+          <a:lstStyle/>
+          <a:p>
+            <a:r>
+              <a:rPr lang="en-GB" dirty="0"/>
+              <a:t>Core Number - Example</a:t>
+            </a:r>
+            <a:endParaRPr lang="en-IL" dirty="0"/>
+          </a:p>
+        </p:txBody>
+      </p:sp>
+      <p:sp>
+        <p:nvSpPr>
+          <p:cNvPr id="4" name="Slide Number Placeholder 3">
+            <a:extLst>
+              <a:ext uri="{FF2B5EF4-FFF2-40B4-BE49-F238E27FC236}">
+                <a16:creationId xmlns:a16="http://schemas.microsoft.com/office/drawing/2014/main" id="{8571681F-8D0E-063B-E5F8-8C7C1145E462}"/>
+              </a:ext>
+            </a:extLst>
+          </p:cNvPr>
+          <p:cNvSpPr>
+            <a:spLocks noGrp="1"/>
+          </p:cNvSpPr>
+          <p:nvPr>
+            <p:ph type="sldNum" sz="quarter" idx="12"/>
+          </p:nvPr>
+        </p:nvSpPr>
+        <p:spPr/>
+        <p:txBody>
+          <a:bodyPr/>
+          <a:lstStyle/>
+          <a:p>
+            <a:fld id="{E6AB8EDD-9EF2-4633-A1C2-4D908C1019B4}" type="slidenum">
+              <a:rPr lang="he-IL" smtClean="0"/>
+              <a:t>8</a:t>
+            </a:fld>
+            <a:endParaRPr lang="he-IL"/>
+          </a:p>
+        </p:txBody>
+      </p:sp>
+      <p:pic>
+        <p:nvPicPr>
+          <p:cNvPr id="3" name="Picture 2" descr="k-Core of a graph">
+            <a:extLst>
+              <a:ext uri="{FF2B5EF4-FFF2-40B4-BE49-F238E27FC236}">
+                <a16:creationId xmlns:a16="http://schemas.microsoft.com/office/drawing/2014/main" id="{3160D834-E7C4-9080-3DC5-CB154A8A5D2B}"/>
+              </a:ext>
+            </a:extLst>
+          </p:cNvPr>
+          <p:cNvPicPr>
+            <a:picLocks noChangeAspect="1"/>
+          </p:cNvPicPr>
+          <p:nvPr/>
+        </p:nvPicPr>
+        <p:blipFill>
+          <a:blip r:embed="rId2"/>
+          <a:stretch>
+            <a:fillRect/>
+          </a:stretch>
+        </p:blipFill>
+        <p:spPr>
+          <a:xfrm>
+            <a:off x="1255283" y="1867838"/>
+            <a:ext cx="10174718" cy="4107071"/>
+          </a:xfrm>
+          <a:prstGeom prst="rect">
+            <a:avLst/>
+          </a:prstGeom>
+        </p:spPr>
+      </p:pic>
+    </p:spTree>
+    <p:extLst>
+      <p:ext uri="{BB962C8B-B14F-4D97-AF65-F5344CB8AC3E}">
+        <p14:creationId xmlns:p14="http://schemas.microsoft.com/office/powerpoint/2010/main" val="2218827271"/>
+      </p:ext>
+    </p:extLst>
+  </p:cSld>
+  <p:clrMapOvr>
+    <a:masterClrMapping/>
+  </p:clrMapOvr>
+</p:sld>
+</file>
+
+<file path=ppt/slides/slide9.xml><?xml version="1.0" encoding="utf-8"?>
 <p:sld xmlns:a="http://schemas.openxmlformats.org/drawingml/2006/main" xmlns:r="http://schemas.openxmlformats.org/officeDocument/2006/relationships" xmlns:p="http://schemas.openxmlformats.org/presentationml/2006/main">
   <p:cSld>
     <p:spTree>
@@ -7458,7 +7881,7 @@
           <a:p>
             <a:r>
               <a:rPr lang="en-GB" dirty="0"/>
-              <a:t>Core Number - Example</a:t>
+              <a:t>Core Number</a:t>
             </a:r>
             <a:endParaRPr lang="en-IL" dirty="0"/>
           </a:p>
@@ -7487,7 +7910,7 @@
           <a:p>
             <a:fld id="{E6AB8EDD-9EF2-4633-A1C2-4D908C1019B4}" type="slidenum">
               <a:rPr lang="he-IL" smtClean="0"/>
-              <a:t>8</a:t>
+              <a:t>9</a:t>
             </a:fld>
             <a:endParaRPr lang="he-IL"/>
           </a:p>
@@ -7523,220 +7946,12 @@
           </a:prstGeom>
         </p:spPr>
       </p:pic>
-    </p:spTree>
-    <p:extLst>
-      <p:ext uri="{BB962C8B-B14F-4D97-AF65-F5344CB8AC3E}">
-        <p14:creationId xmlns:p14="http://schemas.microsoft.com/office/powerpoint/2010/main" val="2218827271"/>
-      </p:ext>
-    </p:extLst>
-  </p:cSld>
-  <p:clrMapOvr>
-    <a:masterClrMapping/>
-  </p:clrMapOvr>
-</p:sld>
-</file>
-
-<file path=ppt/slides/slide9.xml><?xml version="1.0" encoding="utf-8"?>
-<p:sld xmlns:a="http://schemas.openxmlformats.org/drawingml/2006/main" xmlns:r="http://schemas.openxmlformats.org/officeDocument/2006/relationships" xmlns:p="http://schemas.openxmlformats.org/presentationml/2006/main">
-  <p:cSld>
-    <p:spTree>
-      <p:nvGrpSpPr>
-        <p:cNvPr id="1" name="">
-          <a:extLst>
-            <a:ext uri="{FF2B5EF4-FFF2-40B4-BE49-F238E27FC236}">
-              <a16:creationId xmlns:a16="http://schemas.microsoft.com/office/drawing/2014/main" id="{F1FAB34D-2D7A-F556-495E-0CBC96104FEC}"/>
-            </a:ext>
-          </a:extLst>
-        </p:cNvPr>
-        <p:cNvGrpSpPr/>
-        <p:nvPr/>
-      </p:nvGrpSpPr>
-      <p:grpSpPr>
-        <a:xfrm>
-          <a:off x="0" y="0"/>
-          <a:ext cx="0" cy="0"/>
-          <a:chOff x="0" y="0"/>
-          <a:chExt cx="0" cy="0"/>
-        </a:xfrm>
-      </p:grpSpPr>
-      <p:pic>
-        <p:nvPicPr>
-          <p:cNvPr id="6" name="Picture 5">
-            <a:extLst>
-              <a:ext uri="{FF2B5EF4-FFF2-40B4-BE49-F238E27FC236}">
-                <a16:creationId xmlns:a16="http://schemas.microsoft.com/office/drawing/2014/main" id="{D1AEA69D-040E-DE12-FF0B-4330D7D19F20}"/>
-              </a:ext>
-            </a:extLst>
-          </p:cNvPr>
-          <p:cNvPicPr>
-            <a:picLocks noChangeAspect="1"/>
-          </p:cNvPicPr>
-          <p:nvPr/>
-        </p:nvPicPr>
-        <p:blipFill>
-          <a:blip r:embed="rId2"/>
-          <a:stretch>
-            <a:fillRect/>
-          </a:stretch>
-        </p:blipFill>
-        <p:spPr>
-          <a:xfrm>
-            <a:off x="269377" y="2061292"/>
-            <a:ext cx="5826623" cy="2735414"/>
-          </a:xfrm>
-          <a:prstGeom prst="rect">
-            <a:avLst/>
-          </a:prstGeom>
-        </p:spPr>
-      </p:pic>
-      <p:pic>
-        <p:nvPicPr>
-          <p:cNvPr id="9" name="Picture 8">
-            <a:extLst>
-              <a:ext uri="{FF2B5EF4-FFF2-40B4-BE49-F238E27FC236}">
-                <a16:creationId xmlns:a16="http://schemas.microsoft.com/office/drawing/2014/main" id="{7E1F8EA2-71D6-580F-81B8-0F2F2C7F43D3}"/>
-              </a:ext>
-            </a:extLst>
-          </p:cNvPr>
-          <p:cNvPicPr>
-            <a:picLocks noChangeAspect="1"/>
-          </p:cNvPicPr>
-          <p:nvPr/>
-        </p:nvPicPr>
-        <p:blipFill>
-          <a:blip r:embed="rId3"/>
-          <a:stretch>
-            <a:fillRect/>
-          </a:stretch>
-        </p:blipFill>
-        <p:spPr>
-          <a:xfrm>
-            <a:off x="6226073" y="2114567"/>
-            <a:ext cx="5599670" cy="2628865"/>
-          </a:xfrm>
-          <a:prstGeom prst="rect">
-            <a:avLst/>
-          </a:prstGeom>
-        </p:spPr>
-      </p:pic>
-      <p:sp>
-        <p:nvSpPr>
-          <p:cNvPr id="2" name="Title 1">
-            <a:extLst>
-              <a:ext uri="{FF2B5EF4-FFF2-40B4-BE49-F238E27FC236}">
-                <a16:creationId xmlns:a16="http://schemas.microsoft.com/office/drawing/2014/main" id="{7A8FD990-DDE6-CBC9-B3A6-00D4121DA222}"/>
-              </a:ext>
-            </a:extLst>
-          </p:cNvPr>
-          <p:cNvSpPr>
-            <a:spLocks noGrp="1"/>
-          </p:cNvSpPr>
-          <p:nvPr>
-            <p:ph type="title"/>
-          </p:nvPr>
-        </p:nvSpPr>
-        <p:spPr/>
-        <p:txBody>
-          <a:bodyPr>
-            <a:normAutofit/>
-          </a:bodyPr>
-          <a:lstStyle/>
-          <a:p>
-            <a:r>
-              <a:rPr lang="en-GB" dirty="0"/>
-              <a:t>Core Number Analysis</a:t>
-            </a:r>
-            <a:br>
-              <a:rPr lang="en-GB" dirty="0"/>
-            </a:br>
-            <a:r>
-              <a:rPr lang="en-GB" sz="2400" dirty="0"/>
-              <a:t>group mode: smaller</a:t>
-            </a:r>
-            <a:endParaRPr lang="en-IL" sz="2400" dirty="0"/>
-          </a:p>
-        </p:txBody>
-      </p:sp>
-      <p:sp>
-        <p:nvSpPr>
-          <p:cNvPr id="3" name="Content Placeholder 2">
-            <a:extLst>
-              <a:ext uri="{FF2B5EF4-FFF2-40B4-BE49-F238E27FC236}">
-                <a16:creationId xmlns:a16="http://schemas.microsoft.com/office/drawing/2014/main" id="{DC55D22E-3792-2DD2-21B2-D8ADB8E10260}"/>
-              </a:ext>
-            </a:extLst>
-          </p:cNvPr>
-          <p:cNvSpPr>
-            <a:spLocks noGrp="1"/>
-          </p:cNvSpPr>
-          <p:nvPr>
-            <p:ph idx="1"/>
-          </p:nvPr>
-        </p:nvSpPr>
-        <p:spPr>
-          <a:xfrm>
-            <a:off x="1243086" y="1825624"/>
-            <a:ext cx="10850301" cy="5004149"/>
-          </a:xfrm>
-        </p:spPr>
-        <p:txBody>
-          <a:bodyPr>
-            <a:normAutofit/>
-          </a:bodyPr>
-          <a:lstStyle/>
-          <a:p>
-            <a:pPr marL="0" indent="0">
-              <a:buNone/>
-            </a:pPr>
-            <a:endParaRPr lang="en-GB" sz="2000" b="1" dirty="0"/>
-          </a:p>
-          <a:p>
-            <a:pPr lvl="2"/>
-            <a:endParaRPr lang="en-GB" sz="1500" dirty="0"/>
-          </a:p>
-          <a:p>
-            <a:pPr marL="914400" lvl="2" indent="0">
-              <a:buNone/>
-            </a:pPr>
-            <a:endParaRPr lang="en-GB" sz="1500" dirty="0"/>
-          </a:p>
-        </p:txBody>
-      </p:sp>
-      <p:sp>
-        <p:nvSpPr>
-          <p:cNvPr id="4" name="Slide Number Placeholder 3">
-            <a:extLst>
-              <a:ext uri="{FF2B5EF4-FFF2-40B4-BE49-F238E27FC236}">
-                <a16:creationId xmlns:a16="http://schemas.microsoft.com/office/drawing/2014/main" id="{C96BD006-7CBF-5F23-2244-43E7DEA5E1B7}"/>
-              </a:ext>
-            </a:extLst>
-          </p:cNvPr>
-          <p:cNvSpPr>
-            <a:spLocks noGrp="1"/>
-          </p:cNvSpPr>
-          <p:nvPr>
-            <p:ph type="sldNum" sz="quarter" idx="12"/>
-          </p:nvPr>
-        </p:nvSpPr>
-        <p:spPr/>
-        <p:txBody>
-          <a:bodyPr/>
-          <a:lstStyle/>
-          <a:p>
-            <a:fld id="{E6AB8EDD-9EF2-4633-A1C2-4D908C1019B4}" type="slidenum">
-              <a:rPr lang="he-IL" smtClean="0"/>
-              <a:t>9</a:t>
-            </a:fld>
-            <a:endParaRPr lang="he-IL"/>
-          </a:p>
-        </p:txBody>
-      </p:sp>
-      <p:sp>
-        <p:nvSpPr>
-          <p:cNvPr id="11" name="TextBox 10">
-            <a:extLst>
-              <a:ext uri="{FF2B5EF4-FFF2-40B4-BE49-F238E27FC236}">
-                <a16:creationId xmlns:a16="http://schemas.microsoft.com/office/drawing/2014/main" id="{4B8F8192-2756-715E-FCCA-8DD01E5AA434}"/>
+      <p:sp>
+        <p:nvSpPr>
+          <p:cNvPr id="5" name="TextBox 4">
+            <a:extLst>
+              <a:ext uri="{FF2B5EF4-FFF2-40B4-BE49-F238E27FC236}">
+                <a16:creationId xmlns:a16="http://schemas.microsoft.com/office/drawing/2014/main" id="{B7502E69-603F-AF94-7CF7-D27C2F884842}"/>
               </a:ext>
             </a:extLst>
           </p:cNvPr>
@@ -7744,9 +7959,9 @@
           <p:nvPr/>
         </p:nvSpPr>
         <p:spPr>
-          <a:xfrm>
-            <a:off x="1527433" y="5217459"/>
-            <a:ext cx="7073153" cy="646331"/>
+          <a:xfrm rot="21258625">
+            <a:off x="6110596" y="1919799"/>
+            <a:ext cx="1377595" cy="338554"/>
           </a:xfrm>
           <a:prstGeom prst="rect">
             <a:avLst/>
@@ -7759,32 +7974,21 @@
           </a:bodyPr>
           <a:lstStyle/>
           <a:p>
-            <a:r>
-              <a:rPr lang="en-GB" b="1" dirty="0"/>
-              <a:t>Group mode: smaller</a:t>
-            </a:r>
-            <a:r>
-              <a:rPr lang="en-GB" dirty="0"/>
-              <a:t> - each point represents authors whose indicator value is </a:t>
-            </a:r>
-            <a:r>
-              <a:rPr lang="en-GB" b="1" dirty="0"/>
-              <a:t>less than</a:t>
-            </a:r>
-            <a:r>
-              <a:rPr lang="en-GB" dirty="0"/>
-              <a:t> the x-axis value.</a:t>
-            </a:r>
-            <a:endParaRPr lang="en-IL" dirty="0"/>
-          </a:p>
-        </p:txBody>
-      </p:sp>
-      <p:sp>
-        <p:nvSpPr>
-          <p:cNvPr id="5" name="TextBox 4">
-            <a:extLst>
-              <a:ext uri="{FF2B5EF4-FFF2-40B4-BE49-F238E27FC236}">
-                <a16:creationId xmlns:a16="http://schemas.microsoft.com/office/drawing/2014/main" id="{41A45B88-BBA4-ED58-4469-C910CCAA9BA6}"/>
+            <a:pPr algn="ctr"/>
+            <a:r>
+              <a:rPr lang="en-GB" sz="1600" dirty="0"/>
+              <a:t>#DeepState</a:t>
+            </a:r>
+            <a:endParaRPr lang="en-IL" sz="1600" dirty="0"/>
+          </a:p>
+        </p:txBody>
+      </p:sp>
+      <p:sp>
+        <p:nvSpPr>
+          <p:cNvPr id="6" name="TextBox 5">
+            <a:extLst>
+              <a:ext uri="{FF2B5EF4-FFF2-40B4-BE49-F238E27FC236}">
+                <a16:creationId xmlns:a16="http://schemas.microsoft.com/office/drawing/2014/main" id="{D42A0732-50ED-1AFC-32AA-3F7B95710760}"/>
               </a:ext>
             </a:extLst>
           </p:cNvPr>
@@ -7792,9 +7996,9 @@
           <p:nvPr/>
         </p:nvSpPr>
         <p:spPr>
-          <a:xfrm>
-            <a:off x="5234722" y="1639613"/>
-            <a:ext cx="2214283" cy="369332"/>
+          <a:xfrm rot="4810671">
+            <a:off x="5646712" y="3149197"/>
+            <a:ext cx="1205152" cy="338554"/>
           </a:xfrm>
           <a:prstGeom prst="rect">
             <a:avLst/>
@@ -7809,21 +8013,727 @@
           <a:p>
             <a:pPr algn="ctr"/>
             <a:r>
-              <a:rPr lang="en-US" dirty="0"/>
-              <a:t>Ecuador </a:t>
-            </a:r>
+              <a:rPr lang="en-GB" sz="1600" dirty="0"/>
+              <a:t>#CoverUp</a:t>
+            </a:r>
+            <a:endParaRPr lang="en-IL" sz="1600" dirty="0"/>
+          </a:p>
+        </p:txBody>
+      </p:sp>
+      <p:sp>
+        <p:nvSpPr>
+          <p:cNvPr id="7" name="TextBox 6">
+            <a:extLst>
+              <a:ext uri="{FF2B5EF4-FFF2-40B4-BE49-F238E27FC236}">
+                <a16:creationId xmlns:a16="http://schemas.microsoft.com/office/drawing/2014/main" id="{05CD94E7-365A-A4A6-5838-0EF7D67EF462}"/>
+              </a:ext>
+            </a:extLst>
+          </p:cNvPr>
+          <p:cNvSpPr txBox="1"/>
+          <p:nvPr/>
+        </p:nvSpPr>
+        <p:spPr>
+          <a:xfrm>
+            <a:off x="6742558" y="3771025"/>
+            <a:ext cx="1477314" cy="338554"/>
+          </a:xfrm>
+          <a:prstGeom prst="rect">
+            <a:avLst/>
+          </a:prstGeom>
+          <a:noFill/>
+        </p:spPr>
+        <p:txBody>
+          <a:bodyPr wrap="square" rtlCol="0">
+            <a:spAutoFit/>
+          </a:bodyPr>
+          <a:lstStyle/>
+          <a:p>
+            <a:pPr algn="ctr"/>
+            <a:r>
+              <a:rPr lang="en-GB" sz="1600" dirty="0"/>
+              <a:t>#TruthExposed</a:t>
+            </a:r>
+            <a:endParaRPr lang="en-IL" sz="1600" dirty="0"/>
+          </a:p>
+        </p:txBody>
+      </p:sp>
+      <p:sp>
+        <p:nvSpPr>
+          <p:cNvPr id="8" name="TextBox 7">
+            <a:extLst>
+              <a:ext uri="{FF2B5EF4-FFF2-40B4-BE49-F238E27FC236}">
+                <a16:creationId xmlns:a16="http://schemas.microsoft.com/office/drawing/2014/main" id="{B2AEAFB6-CF99-FD38-EFA5-9E066A7D1940}"/>
+              </a:ext>
+            </a:extLst>
+          </p:cNvPr>
+          <p:cNvSpPr txBox="1"/>
+          <p:nvPr/>
+        </p:nvSpPr>
+        <p:spPr>
+          <a:xfrm rot="4119364">
+            <a:off x="7794291" y="2828263"/>
+            <a:ext cx="1377595" cy="338554"/>
+          </a:xfrm>
+          <a:prstGeom prst="rect">
+            <a:avLst/>
+          </a:prstGeom>
+          <a:noFill/>
+        </p:spPr>
+        <p:txBody>
+          <a:bodyPr wrap="square" rtlCol="0">
+            <a:spAutoFit/>
+          </a:bodyPr>
+          <a:lstStyle/>
+          <a:p>
+            <a:pPr algn="ctr"/>
+            <a:r>
+              <a:rPr lang="en-GB" sz="1600" dirty="0"/>
+              <a:t>#DeepState</a:t>
+            </a:r>
+            <a:endParaRPr lang="en-IL" sz="1600" dirty="0"/>
+          </a:p>
+        </p:txBody>
+      </p:sp>
+      <p:sp>
+        <p:nvSpPr>
+          <p:cNvPr id="9" name="TextBox 8">
+            <a:extLst>
+              <a:ext uri="{FF2B5EF4-FFF2-40B4-BE49-F238E27FC236}">
+                <a16:creationId xmlns:a16="http://schemas.microsoft.com/office/drawing/2014/main" id="{17EDC16A-3C4E-B233-A738-0736FE8DA8F5}"/>
+              </a:ext>
+            </a:extLst>
+          </p:cNvPr>
+          <p:cNvSpPr txBox="1"/>
+          <p:nvPr/>
+        </p:nvSpPr>
+        <p:spPr>
+          <a:xfrm rot="1762880">
+            <a:off x="7204790" y="3201896"/>
+            <a:ext cx="1205152" cy="338554"/>
+          </a:xfrm>
+          <a:prstGeom prst="rect">
+            <a:avLst/>
+          </a:prstGeom>
+          <a:noFill/>
+        </p:spPr>
+        <p:txBody>
+          <a:bodyPr wrap="square" rtlCol="0">
+            <a:spAutoFit/>
+          </a:bodyPr>
+          <a:lstStyle/>
+          <a:p>
+            <a:pPr algn="ctr"/>
+            <a:r>
+              <a:rPr lang="en-GB" sz="1600" dirty="0"/>
+              <a:t>#CoverUp</a:t>
+            </a:r>
+            <a:endParaRPr lang="en-IL" sz="1600" dirty="0"/>
+          </a:p>
+        </p:txBody>
+      </p:sp>
+      <p:sp>
+        <p:nvSpPr>
+          <p:cNvPr id="10" name="TextBox 9">
+            <a:extLst>
+              <a:ext uri="{FF2B5EF4-FFF2-40B4-BE49-F238E27FC236}">
+                <a16:creationId xmlns:a16="http://schemas.microsoft.com/office/drawing/2014/main" id="{9B4E0D75-2DDB-A370-7E53-455AEB5ABECD}"/>
+              </a:ext>
+            </a:extLst>
+          </p:cNvPr>
+          <p:cNvSpPr txBox="1"/>
+          <p:nvPr/>
+        </p:nvSpPr>
+        <p:spPr>
+          <a:xfrm rot="18366777">
+            <a:off x="6630407" y="2490587"/>
+            <a:ext cx="1205152" cy="338554"/>
+          </a:xfrm>
+          <a:prstGeom prst="rect">
+            <a:avLst/>
+          </a:prstGeom>
+          <a:noFill/>
+        </p:spPr>
+        <p:txBody>
+          <a:bodyPr wrap="square" rtlCol="0">
+            <a:spAutoFit/>
+          </a:bodyPr>
+          <a:lstStyle/>
+          <a:p>
+            <a:pPr algn="ctr"/>
+            <a:r>
+              <a:rPr lang="en-GB" sz="1600" dirty="0"/>
+              <a:t>#True</a:t>
+            </a:r>
+            <a:endParaRPr lang="en-IL" sz="1600" dirty="0"/>
+          </a:p>
+        </p:txBody>
+      </p:sp>
+      <p:sp>
+        <p:nvSpPr>
+          <p:cNvPr id="14" name="TextBox 13">
+            <a:extLst>
+              <a:ext uri="{FF2B5EF4-FFF2-40B4-BE49-F238E27FC236}">
+                <a16:creationId xmlns:a16="http://schemas.microsoft.com/office/drawing/2014/main" id="{EBDBF434-BC13-F47A-9E0A-990355917FA9}"/>
+              </a:ext>
+            </a:extLst>
+          </p:cNvPr>
+          <p:cNvSpPr txBox="1"/>
+          <p:nvPr/>
+        </p:nvSpPr>
+        <p:spPr>
+          <a:xfrm>
+            <a:off x="4618686" y="3805712"/>
+            <a:ext cx="1477314" cy="338554"/>
+          </a:xfrm>
+          <a:prstGeom prst="rect">
+            <a:avLst/>
+          </a:prstGeom>
+          <a:noFill/>
+        </p:spPr>
+        <p:txBody>
+          <a:bodyPr wrap="square" rtlCol="0">
+            <a:spAutoFit/>
+          </a:bodyPr>
+          <a:lstStyle/>
+          <a:p>
+            <a:pPr algn="ctr"/>
+            <a:r>
+              <a:rPr lang="en-GB" sz="1600" dirty="0"/>
+              <a:t>#Trending</a:t>
+            </a:r>
+            <a:endParaRPr lang="en-IL" sz="1600" dirty="0"/>
+          </a:p>
+        </p:txBody>
+      </p:sp>
+      <p:sp>
+        <p:nvSpPr>
+          <p:cNvPr id="16" name="TextBox 15">
+            <a:extLst>
+              <a:ext uri="{FF2B5EF4-FFF2-40B4-BE49-F238E27FC236}">
+                <a16:creationId xmlns:a16="http://schemas.microsoft.com/office/drawing/2014/main" id="{162FEE4E-9909-A2EA-D4C0-7C567C0D81B3}"/>
+              </a:ext>
+            </a:extLst>
+          </p:cNvPr>
+          <p:cNvSpPr txBox="1"/>
+          <p:nvPr/>
+        </p:nvSpPr>
+        <p:spPr>
+          <a:xfrm rot="3114557">
+            <a:off x="9656857" y="2508597"/>
+            <a:ext cx="1377595" cy="338554"/>
+          </a:xfrm>
+          <a:prstGeom prst="rect">
+            <a:avLst/>
+          </a:prstGeom>
+          <a:noFill/>
+        </p:spPr>
+        <p:txBody>
+          <a:bodyPr wrap="square" rtlCol="0">
+            <a:spAutoFit/>
+          </a:bodyPr>
+          <a:lstStyle/>
+          <a:p>
+            <a:pPr algn="ctr"/>
+            <a:r>
+              <a:rPr lang="en-GB" sz="1600" dirty="0"/>
+              <a:t>#Music</a:t>
+            </a:r>
+            <a:endParaRPr lang="en-IL" sz="1600" dirty="0"/>
+          </a:p>
+        </p:txBody>
+      </p:sp>
+      <p:sp>
+        <p:nvSpPr>
+          <p:cNvPr id="18" name="TextBox 17">
+            <a:extLst>
+              <a:ext uri="{FF2B5EF4-FFF2-40B4-BE49-F238E27FC236}">
+                <a16:creationId xmlns:a16="http://schemas.microsoft.com/office/drawing/2014/main" id="{1617E1FF-92A9-A019-1A6C-4BE0291EDC76}"/>
+              </a:ext>
+            </a:extLst>
+          </p:cNvPr>
+          <p:cNvSpPr txBox="1"/>
+          <p:nvPr/>
+        </p:nvSpPr>
+        <p:spPr>
+          <a:xfrm rot="17535076">
+            <a:off x="8457906" y="2864984"/>
+            <a:ext cx="1377595" cy="338554"/>
+          </a:xfrm>
+          <a:prstGeom prst="rect">
+            <a:avLst/>
+          </a:prstGeom>
+          <a:noFill/>
+        </p:spPr>
+        <p:txBody>
+          <a:bodyPr wrap="square" rtlCol="0">
+            <a:spAutoFit/>
+          </a:bodyPr>
+          <a:lstStyle/>
+          <a:p>
+            <a:pPr algn="ctr"/>
+            <a:r>
+              <a:rPr lang="en-GB" sz="1600" dirty="0"/>
+              <a:t>#DeepState</a:t>
+            </a:r>
+            <a:endParaRPr lang="en-IL" sz="1600" dirty="0"/>
+          </a:p>
+        </p:txBody>
+      </p:sp>
+      <p:sp>
+        <p:nvSpPr>
+          <p:cNvPr id="21" name="TextBox 20">
+            <a:extLst>
+              <a:ext uri="{FF2B5EF4-FFF2-40B4-BE49-F238E27FC236}">
+                <a16:creationId xmlns:a16="http://schemas.microsoft.com/office/drawing/2014/main" id="{F51BF22E-50BE-4ECE-923D-B4BF2FC677C0}"/>
+              </a:ext>
+            </a:extLst>
+          </p:cNvPr>
+          <p:cNvSpPr txBox="1"/>
+          <p:nvPr/>
+        </p:nvSpPr>
+        <p:spPr>
+          <a:xfrm>
+            <a:off x="9656856" y="1791741"/>
+            <a:ext cx="1377595" cy="338554"/>
+          </a:xfrm>
+          <a:prstGeom prst="rect">
+            <a:avLst/>
+          </a:prstGeom>
+          <a:noFill/>
+        </p:spPr>
+        <p:txBody>
+          <a:bodyPr wrap="square" rtlCol="0">
+            <a:spAutoFit/>
+          </a:bodyPr>
+          <a:lstStyle/>
+          <a:p>
+            <a:pPr algn="ctr"/>
+            <a:r>
+              <a:rPr lang="en-GB" sz="1600" dirty="0"/>
+              <a:t>#Music</a:t>
+            </a:r>
+            <a:endParaRPr lang="en-IL" sz="1600" dirty="0"/>
+          </a:p>
+        </p:txBody>
+      </p:sp>
+      <p:sp>
+        <p:nvSpPr>
+          <p:cNvPr id="22" name="TextBox 21">
+            <a:extLst>
+              <a:ext uri="{FF2B5EF4-FFF2-40B4-BE49-F238E27FC236}">
+                <a16:creationId xmlns:a16="http://schemas.microsoft.com/office/drawing/2014/main" id="{B8E9EBA8-814F-F059-2FF1-53ED509537FF}"/>
+              </a:ext>
+            </a:extLst>
+          </p:cNvPr>
+          <p:cNvSpPr txBox="1"/>
+          <p:nvPr/>
+        </p:nvSpPr>
+        <p:spPr>
+          <a:xfrm rot="18686069">
+            <a:off x="9453556" y="4603411"/>
+            <a:ext cx="1377595" cy="338554"/>
+          </a:xfrm>
+          <a:prstGeom prst="rect">
+            <a:avLst/>
+          </a:prstGeom>
+          <a:noFill/>
+        </p:spPr>
+        <p:txBody>
+          <a:bodyPr wrap="square" rtlCol="0">
+            <a:spAutoFit/>
+          </a:bodyPr>
+          <a:lstStyle/>
+          <a:p>
+            <a:pPr algn="ctr"/>
+            <a:r>
+              <a:rPr lang="en-GB" sz="1600" dirty="0"/>
+              <a:t>#Eurovision</a:t>
+            </a:r>
+            <a:endParaRPr lang="en-IL" sz="1600" dirty="0"/>
+          </a:p>
+        </p:txBody>
+      </p:sp>
+      <p:sp>
+        <p:nvSpPr>
+          <p:cNvPr id="23" name="TextBox 22">
+            <a:extLst>
+              <a:ext uri="{FF2B5EF4-FFF2-40B4-BE49-F238E27FC236}">
+                <a16:creationId xmlns:a16="http://schemas.microsoft.com/office/drawing/2014/main" id="{7C117F96-65E5-BA1F-C866-9E834A2624AC}"/>
+              </a:ext>
+            </a:extLst>
+          </p:cNvPr>
+          <p:cNvSpPr txBox="1"/>
+          <p:nvPr/>
+        </p:nvSpPr>
+        <p:spPr>
+          <a:xfrm rot="20634719">
+            <a:off x="9166637" y="3480230"/>
+            <a:ext cx="1377595" cy="338554"/>
+          </a:xfrm>
+          <a:prstGeom prst="rect">
+            <a:avLst/>
+          </a:prstGeom>
+          <a:noFill/>
+        </p:spPr>
+        <p:txBody>
+          <a:bodyPr wrap="square" rtlCol="0">
+            <a:spAutoFit/>
+          </a:bodyPr>
+          <a:lstStyle/>
+          <a:p>
+            <a:pPr algn="ctr"/>
+            <a:r>
+              <a:rPr lang="en-GB" sz="1600" dirty="0"/>
+              <a:t># Media</a:t>
+            </a:r>
+            <a:endParaRPr lang="en-IL" sz="1600" dirty="0"/>
+          </a:p>
+        </p:txBody>
+      </p:sp>
+      <p:sp>
+        <p:nvSpPr>
+          <p:cNvPr id="24" name="TextBox 23">
+            <a:extLst>
+              <a:ext uri="{FF2B5EF4-FFF2-40B4-BE49-F238E27FC236}">
+                <a16:creationId xmlns:a16="http://schemas.microsoft.com/office/drawing/2014/main" id="{784A7900-1718-9498-D12B-BF6EFF07BB99}"/>
+              </a:ext>
+            </a:extLst>
+          </p:cNvPr>
+          <p:cNvSpPr txBox="1"/>
+          <p:nvPr/>
+        </p:nvSpPr>
+        <p:spPr>
+          <a:xfrm rot="15751676">
+            <a:off x="8165907" y="4724186"/>
+            <a:ext cx="1377595" cy="369332"/>
+          </a:xfrm>
+          <a:prstGeom prst="rect">
+            <a:avLst/>
+          </a:prstGeom>
+          <a:noFill/>
+        </p:spPr>
+        <p:txBody>
+          <a:bodyPr wrap="square" rtlCol="0">
+            <a:spAutoFit/>
+          </a:bodyPr>
+          <a:lstStyle/>
+          <a:p>
+            <a:pPr algn="ctr"/>
             <a:r>
               <a:rPr lang="en-GB" dirty="0"/>
-              <a:t>Campaigns</a:t>
-            </a:r>
-            <a:endParaRPr lang="en-IL" dirty="0"/>
-          </a:p>
-        </p:txBody>
-      </p:sp>
+              <a:t>#</a:t>
+            </a:r>
+            <a:r>
+              <a:rPr lang="en-GB" sz="1600" dirty="0"/>
+              <a:t>DeepState</a:t>
+            </a:r>
+            <a:endParaRPr lang="en-IL" sz="1600" dirty="0"/>
+          </a:p>
+        </p:txBody>
+      </p:sp>
+      <p:sp>
+        <p:nvSpPr>
+          <p:cNvPr id="25" name="TextBox 24">
+            <a:extLst>
+              <a:ext uri="{FF2B5EF4-FFF2-40B4-BE49-F238E27FC236}">
+                <a16:creationId xmlns:a16="http://schemas.microsoft.com/office/drawing/2014/main" id="{CFE119A9-EA7D-D216-1015-8751196133B7}"/>
+              </a:ext>
+            </a:extLst>
+          </p:cNvPr>
+          <p:cNvSpPr txBox="1"/>
+          <p:nvPr/>
+        </p:nvSpPr>
+        <p:spPr>
+          <a:xfrm rot="5187585">
+            <a:off x="5916302" y="4788727"/>
+            <a:ext cx="1205152" cy="338554"/>
+          </a:xfrm>
+          <a:prstGeom prst="rect">
+            <a:avLst/>
+          </a:prstGeom>
+          <a:noFill/>
+        </p:spPr>
+        <p:txBody>
+          <a:bodyPr wrap="square" rtlCol="0">
+            <a:spAutoFit/>
+          </a:bodyPr>
+          <a:lstStyle/>
+          <a:p>
+            <a:pPr algn="ctr"/>
+            <a:r>
+              <a:rPr lang="en-GB" sz="1600" dirty="0"/>
+              <a:t>#True</a:t>
+            </a:r>
+            <a:endParaRPr lang="en-IL" sz="1600" dirty="0"/>
+          </a:p>
+        </p:txBody>
+      </p:sp>
+      <p:sp>
+        <p:nvSpPr>
+          <p:cNvPr id="27" name="TextBox 26">
+            <a:extLst>
+              <a:ext uri="{FF2B5EF4-FFF2-40B4-BE49-F238E27FC236}">
+                <a16:creationId xmlns:a16="http://schemas.microsoft.com/office/drawing/2014/main" id="{D530366B-B9BA-ED1C-15BE-7915DA9DF1F3}"/>
+              </a:ext>
+            </a:extLst>
+          </p:cNvPr>
+          <p:cNvSpPr txBox="1"/>
+          <p:nvPr/>
+        </p:nvSpPr>
+        <p:spPr>
+          <a:xfrm rot="18445421">
+            <a:off x="4377158" y="2864983"/>
+            <a:ext cx="1205152" cy="338554"/>
+          </a:xfrm>
+          <a:prstGeom prst="rect">
+            <a:avLst/>
+          </a:prstGeom>
+          <a:noFill/>
+        </p:spPr>
+        <p:txBody>
+          <a:bodyPr wrap="square" rtlCol="0">
+            <a:spAutoFit/>
+          </a:bodyPr>
+          <a:lstStyle/>
+          <a:p>
+            <a:pPr algn="ctr"/>
+            <a:r>
+              <a:rPr lang="en-GB" sz="1600" dirty="0"/>
+              <a:t>#CoverUp</a:t>
+            </a:r>
+            <a:endParaRPr lang="en-IL" sz="1600" dirty="0"/>
+          </a:p>
+        </p:txBody>
+      </p:sp>
+      <p:sp>
+        <p:nvSpPr>
+          <p:cNvPr id="28" name="TextBox 27">
+            <a:extLst>
+              <a:ext uri="{FF2B5EF4-FFF2-40B4-BE49-F238E27FC236}">
+                <a16:creationId xmlns:a16="http://schemas.microsoft.com/office/drawing/2014/main" id="{BE57D533-B730-0F94-C987-C8468DA9FC9F}"/>
+              </a:ext>
+            </a:extLst>
+          </p:cNvPr>
+          <p:cNvSpPr txBox="1"/>
+          <p:nvPr/>
+        </p:nvSpPr>
+        <p:spPr>
+          <a:xfrm rot="4499005">
+            <a:off x="3739807" y="2936281"/>
+            <a:ext cx="1205152" cy="338554"/>
+          </a:xfrm>
+          <a:prstGeom prst="rect">
+            <a:avLst/>
+          </a:prstGeom>
+          <a:noFill/>
+        </p:spPr>
+        <p:txBody>
+          <a:bodyPr wrap="square" rtlCol="0">
+            <a:spAutoFit/>
+          </a:bodyPr>
+          <a:lstStyle/>
+          <a:p>
+            <a:pPr algn="ctr"/>
+            <a:r>
+              <a:rPr lang="en-GB" sz="1600" dirty="0"/>
+              <a:t>#CoverUp</a:t>
+            </a:r>
+            <a:endParaRPr lang="en-IL" sz="1600" dirty="0"/>
+          </a:p>
+        </p:txBody>
+      </p:sp>
+      <p:sp>
+        <p:nvSpPr>
+          <p:cNvPr id="30" name="TextBox 29">
+            <a:extLst>
+              <a:ext uri="{FF2B5EF4-FFF2-40B4-BE49-F238E27FC236}">
+                <a16:creationId xmlns:a16="http://schemas.microsoft.com/office/drawing/2014/main" id="{7D21E3F1-3775-B1D3-C89B-6A19DF5C7C01}"/>
+              </a:ext>
+            </a:extLst>
+          </p:cNvPr>
+          <p:cNvSpPr txBox="1"/>
+          <p:nvPr/>
+        </p:nvSpPr>
+        <p:spPr>
+          <a:xfrm rot="17463090">
+            <a:off x="3407513" y="4683885"/>
+            <a:ext cx="1205152" cy="338554"/>
+          </a:xfrm>
+          <a:prstGeom prst="rect">
+            <a:avLst/>
+          </a:prstGeom>
+          <a:noFill/>
+        </p:spPr>
+        <p:txBody>
+          <a:bodyPr wrap="square" rtlCol="0">
+            <a:spAutoFit/>
+          </a:bodyPr>
+          <a:lstStyle/>
+          <a:p>
+            <a:pPr algn="ctr"/>
+            <a:r>
+              <a:rPr lang="en-GB" sz="1600" dirty="0"/>
+              <a:t>#CoverUp</a:t>
+            </a:r>
+            <a:endParaRPr lang="en-IL" sz="1600" dirty="0"/>
+          </a:p>
+        </p:txBody>
+      </p:sp>
+      <p:sp>
+        <p:nvSpPr>
+          <p:cNvPr id="31" name="TextBox 30">
+            <a:extLst>
+              <a:ext uri="{FF2B5EF4-FFF2-40B4-BE49-F238E27FC236}">
+                <a16:creationId xmlns:a16="http://schemas.microsoft.com/office/drawing/2014/main" id="{1B9AD731-D0B0-5AFB-2AB3-95826840118E}"/>
+              </a:ext>
+            </a:extLst>
+          </p:cNvPr>
+          <p:cNvSpPr txBox="1"/>
+          <p:nvPr/>
+        </p:nvSpPr>
+        <p:spPr>
+          <a:xfrm rot="1702415">
+            <a:off x="7159342" y="4609927"/>
+            <a:ext cx="1377595" cy="338554"/>
+          </a:xfrm>
+          <a:prstGeom prst="rect">
+            <a:avLst/>
+          </a:prstGeom>
+          <a:noFill/>
+        </p:spPr>
+        <p:txBody>
+          <a:bodyPr wrap="square" rtlCol="0">
+            <a:spAutoFit/>
+          </a:bodyPr>
+          <a:lstStyle/>
+          <a:p>
+            <a:pPr algn="ctr"/>
+            <a:r>
+              <a:rPr lang="en-GB" sz="1600" dirty="0"/>
+              <a:t># Media</a:t>
+            </a:r>
+            <a:endParaRPr lang="en-IL" sz="1600" dirty="0"/>
+          </a:p>
+        </p:txBody>
+      </p:sp>
+      <mc:AlternateContent xmlns:mc="http://schemas.openxmlformats.org/markup-compatibility/2006">
+        <mc:Choice xmlns:a14="http://schemas.microsoft.com/office/drawing/2010/main" Requires="a14">
+          <p:sp>
+            <p:nvSpPr>
+              <p:cNvPr id="33" name="TextBox 32">
+                <a:extLst>
+                  <a:ext uri="{FF2B5EF4-FFF2-40B4-BE49-F238E27FC236}">
+                    <a16:creationId xmlns:a16="http://schemas.microsoft.com/office/drawing/2014/main" id="{0F115F42-0B0F-4345-6BB3-C0BBE90FDB99}"/>
+                  </a:ext>
+                </a:extLst>
+              </p:cNvPr>
+              <p:cNvSpPr txBox="1"/>
+              <p:nvPr/>
+            </p:nvSpPr>
+            <p:spPr>
+              <a:xfrm>
+                <a:off x="1255283" y="6076537"/>
+                <a:ext cx="7976266" cy="707886"/>
+              </a:xfrm>
+              <a:prstGeom prst="rect">
+                <a:avLst/>
+              </a:prstGeom>
+              <a:noFill/>
+            </p:spPr>
+            <p:txBody>
+              <a:bodyPr wrap="square">
+                <a:spAutoFit/>
+              </a:bodyPr>
+              <a:lstStyle/>
+              <a:p>
+                <a:r>
+                  <a:rPr lang="en-GB" sz="2000" dirty="0"/>
+                  <a:t>A node’s core number is the largest </a:t>
+                </a:r>
+                <a14:m>
+                  <m:oMath xmlns:m="http://schemas.openxmlformats.org/officeDocument/2006/math">
+                    <m:r>
+                      <a:rPr lang="en-GB" sz="2000"/>
+                      <m:t>𝑘</m:t>
+                    </m:r>
+                    <m:r>
+                      <a:rPr lang="en-US" sz="2000" b="0" i="0" smtClean="0">
+                        <a:latin typeface="Cambria Math" panose="02040503050406030204" pitchFamily="18" charset="0"/>
+                      </a:rPr>
+                      <m:t> </m:t>
+                    </m:r>
+                  </m:oMath>
+                </a14:m>
+                <a:r>
+                  <a:rPr lang="en-GB" sz="2000" dirty="0"/>
+                  <a:t>such that the node belongs to a subgraph where every node has at least </a:t>
+                </a:r>
+                <a14:m>
+                  <m:oMath xmlns:m="http://schemas.openxmlformats.org/officeDocument/2006/math">
+                    <m:r>
+                      <a:rPr lang="en-GB" sz="2000"/>
+                      <m:t>𝑘</m:t>
+                    </m:r>
+                  </m:oMath>
+                </a14:m>
+                <a:r>
+                  <a:rPr lang="en-GB" sz="2000" dirty="0"/>
+                  <a:t>neighbours within that subgraph.</a:t>
+                </a:r>
+                <a:endParaRPr lang="en-IL" sz="2000" dirty="0"/>
+              </a:p>
+            </p:txBody>
+          </p:sp>
+        </mc:Choice>
+        <mc:Fallback>
+          <p:sp>
+            <p:nvSpPr>
+              <p:cNvPr id="33" name="TextBox 32">
+                <a:extLst>
+                  <a:ext uri="{FF2B5EF4-FFF2-40B4-BE49-F238E27FC236}">
+                    <a16:creationId xmlns:a16="http://schemas.microsoft.com/office/drawing/2014/main" id="{0F115F42-0B0F-4345-6BB3-C0BBE90FDB99}"/>
+                  </a:ext>
+                </a:extLst>
+              </p:cNvPr>
+              <p:cNvSpPr txBox="1">
+                <a:spLocks noRot="1" noChangeAspect="1" noMove="1" noResize="1" noEditPoints="1" noAdjustHandles="1" noChangeArrowheads="1" noChangeShapeType="1" noTextEdit="1"/>
+              </p:cNvSpPr>
+              <p:nvPr/>
+            </p:nvSpPr>
+            <p:spPr>
+              <a:xfrm>
+                <a:off x="1255283" y="6076537"/>
+                <a:ext cx="7976266" cy="707886"/>
+              </a:xfrm>
+              <a:prstGeom prst="rect">
+                <a:avLst/>
+              </a:prstGeom>
+              <a:blipFill>
+                <a:blip r:embed="rId3"/>
+                <a:stretch>
+                  <a:fillRect l="-841" t="-5172" r="-153" b="-14655"/>
+                </a:stretch>
+              </a:blipFill>
+            </p:spPr>
+            <p:txBody>
+              <a:bodyPr/>
+              <a:lstStyle/>
+              <a:p>
+                <a:r>
+                  <a:rPr lang="en-IL">
+                    <a:noFill/>
+                  </a:rPr>
+                  <a:t> </a:t>
+                </a:r>
+              </a:p>
+            </p:txBody>
+          </p:sp>
+        </mc:Fallback>
+      </mc:AlternateContent>
     </p:spTree>
     <p:extLst>
       <p:ext uri="{BB962C8B-B14F-4D97-AF65-F5344CB8AC3E}">
-        <p14:creationId xmlns:p14="http://schemas.microsoft.com/office/powerpoint/2010/main" val="3953363932"/>
+        <p14:creationId xmlns:p14="http://schemas.microsoft.com/office/powerpoint/2010/main" val="550127512"/>
       </p:ext>
     </p:extLst>
   </p:cSld>

</xml_diff>